<commit_message>
Billwise Invoice Automation  Platform
</commit_message>
<xml_diff>
--- a/BillWise_Case_Study_Presentation.pptx
+++ b/BillWise_Case_Study_Presentation.pptx
@@ -1432,7 +1432,7 @@
               <a:buNone/>
             </a:pPr>
             <a:r>
-              <a:rPr lang="en-US" sz="1100" b="1" dirty="0">
+              <a:rPr lang="en-US" sz="1100" b="1" dirty="0" err="1">
                 <a:solidFill>
                   <a:srgbClr val="CADCFC"/>
                 </a:solidFill>
@@ -1440,7 +1440,7 @@
                 <a:ea typeface="Calibri" pitchFamily="34" charset="-122"/>
                 <a:cs typeface="Calibri" pitchFamily="34" charset="-120"/>
               </a:rPr>
-              <a:t>MYSQL</a:t>
+              <a:t>PostGreSQL</a:t>
             </a:r>
             <a:endParaRPr lang="en-US" sz="1100" dirty="0"/>
           </a:p>
@@ -6945,7 +6945,7 @@
                 <a:ea typeface="Calibri" pitchFamily="34" charset="-122"/>
                 <a:cs typeface="Calibri" pitchFamily="34" charset="-120"/>
               </a:rPr>
-              <a:t>MySQL (H2 for tests); Flyway or Liquibase migrations + seed data</a:t>
+              <a:t>PostgreSQL (H2 for tests); Flyway or Liquibase migrations + seed data</a:t>
             </a:r>
             <a:endParaRPr lang="en-US" sz="1050" dirty="0"/>
           </a:p>

</xml_diff>